<commit_message>
Add cell padding and balanced margins to tables
</commit_message>
<xml_diff>
--- a/gallery/renders/markdown_tables_complex.pptx
+++ b/gallery/renders/markdown_tables_complex.pptx
@@ -67,8 +67,8 @@
           <p:nvPr/>
         </p:nvGraphicFramePr>
         <p:xfrm>
-          <a:off x="910336" y="2838907"/>
-          <a:ext cx="11184128" cy="1097280"/>
+          <a:off x="910336" y="2991307"/>
+          <a:ext cx="11184128" cy="1371600"/>
         </p:xfrm>
         <a:graphic>
           <a:graphicData uri="http://schemas.openxmlformats.org/drawingml/2006/table">
@@ -80,7 +80,7 @@
                 <a:gridCol w="2796032"/>
                 <a:gridCol w="2796032"/>
               </a:tblGrid>
-              <a:tr h="365760">
+              <a:tr h="457200">
                 <a:tc>
                   <a:txBody>
                     <a:bodyPr/>
@@ -238,7 +238,7 @@
                   </a:tcPr>
                 </a:tc>
               </a:tr>
-              <a:tr h="365760">
+              <a:tr h="457200">
                 <a:tc>
                   <a:txBody>
                     <a:bodyPr/>
@@ -408,7 +408,7 @@
                   </a:tcPr>
                 </a:tc>
               </a:tr>
-              <a:tr h="365760">
+              <a:tr h="457200">
                 <a:tc>
                   <a:txBody>
                     <a:bodyPr/>
@@ -578,7 +578,7 @@
         </p:nvSpPr>
         <p:spPr>
           <a:xfrm>
-            <a:off x="910336" y="3951427"/>
+            <a:off x="910336" y="4515307"/>
             <a:ext cx="11184128" cy="731520"/>
           </a:xfrm>
           <a:prstGeom prst="rect">

</xml_diff>